<commit_message>
slight tweaks to slides
</commit_message>
<xml_diff>
--- a/doc/presentation/Thesis.pptx
+++ b/doc/presentation/Thesis.pptx
@@ -5,7 +5,7 @@
     <p:sldMasterId id="2147483648" r:id="rId1"/>
   </p:sldMasterIdLst>
   <p:notesMasterIdLst>
-    <p:notesMasterId r:id="rId55"/>
+    <p:notesMasterId r:id="rId56"/>
   </p:notesMasterIdLst>
   <p:sldIdLst>
     <p:sldId id="256" r:id="rId2"/>
@@ -50,17 +50,18 @@
     <p:sldId id="329" r:id="rId41"/>
     <p:sldId id="319" r:id="rId42"/>
     <p:sldId id="268" r:id="rId43"/>
-    <p:sldId id="277" r:id="rId44"/>
-    <p:sldId id="269" r:id="rId45"/>
-    <p:sldId id="328" r:id="rId46"/>
-    <p:sldId id="317" r:id="rId47"/>
-    <p:sldId id="258" r:id="rId48"/>
-    <p:sldId id="326" r:id="rId49"/>
-    <p:sldId id="320" r:id="rId50"/>
-    <p:sldId id="327" r:id="rId51"/>
-    <p:sldId id="274" r:id="rId52"/>
-    <p:sldId id="259" r:id="rId53"/>
-    <p:sldId id="260" r:id="rId54"/>
+    <p:sldId id="330" r:id="rId44"/>
+    <p:sldId id="277" r:id="rId45"/>
+    <p:sldId id="269" r:id="rId46"/>
+    <p:sldId id="328" r:id="rId47"/>
+    <p:sldId id="317" r:id="rId48"/>
+    <p:sldId id="258" r:id="rId49"/>
+    <p:sldId id="326" r:id="rId50"/>
+    <p:sldId id="320" r:id="rId51"/>
+    <p:sldId id="327" r:id="rId52"/>
+    <p:sldId id="274" r:id="rId53"/>
+    <p:sldId id="259" r:id="rId54"/>
+    <p:sldId id="260" r:id="rId55"/>
   </p:sldIdLst>
   <p:sldSz cx="12192000" cy="6858000"/>
   <p:notesSz cx="6858000" cy="9144000"/>
@@ -234,6 +235,7 @@
         <p14:section name="Q&amp;A" id="{4132604F-A5FF-4E6F-A51C-CD14EC1306E2}">
           <p14:sldIdLst>
             <p14:sldId id="268"/>
+            <p14:sldId id="330"/>
           </p14:sldIdLst>
         </p14:section>
         <p14:section name="Backup / Extra Examples" id="{274778F2-46BC-4298-9911-D5D9332C2A83}">
@@ -4036,6 +4038,93 @@
           </p:nvPr>
         </p:nvSpPr>
         <p:spPr/>
+      </p:sp>
+      <p:sp>
+        <p:nvSpPr>
+          <p:cNvPr id="3" name="Notes Placeholder 2"/>
+          <p:cNvSpPr>
+            <a:spLocks noGrp="1"/>
+          </p:cNvSpPr>
+          <p:nvPr>
+            <p:ph type="body" idx="1"/>
+          </p:nvPr>
+        </p:nvSpPr>
+        <p:spPr/>
+        <p:txBody>
+          <a:bodyPr/>
+          <a:lstStyle/>
+          <a:p>
+            <a:r>
+              <a:rPr lang="en-CH" dirty="0"/>
+              <a:t>market share is really % of TVL</a:t>
+            </a:r>
+          </a:p>
+        </p:txBody>
+      </p:sp>
+      <p:sp>
+        <p:nvSpPr>
+          <p:cNvPr id="4" name="Slide Number Placeholder 3"/>
+          <p:cNvSpPr>
+            <a:spLocks noGrp="1"/>
+          </p:cNvSpPr>
+          <p:nvPr>
+            <p:ph type="sldNum" sz="quarter" idx="5"/>
+          </p:nvPr>
+        </p:nvSpPr>
+        <p:spPr/>
+        <p:txBody>
+          <a:bodyPr/>
+          <a:lstStyle/>
+          <a:p>
+            <a:fld id="{ADB26BFD-26FA-41FF-A418-AE5D5C01BD91}" type="slidenum">
+              <a:rPr lang="en-CH" smtClean="0"/>
+              <a:t>7</a:t>
+            </a:fld>
+            <a:endParaRPr lang="en-CH"/>
+          </a:p>
+        </p:txBody>
+      </p:sp>
+    </p:spTree>
+    <p:extLst>
+      <p:ext uri="{BB962C8B-B14F-4D97-AF65-F5344CB8AC3E}">
+        <p14:creationId xmlns:p14="http://schemas.microsoft.com/office/powerpoint/2010/main" val="1272181008"/>
+      </p:ext>
+    </p:extLst>
+  </p:cSld>
+  <p:clrMapOvr>
+    <a:masterClrMapping/>
+  </p:clrMapOvr>
+</p:notes>
+</file>
+
+<file path=ppt/notesSlides/notesSlide2.xml><?xml version="1.0" encoding="utf-8"?>
+<p:notes xmlns:a="http://schemas.openxmlformats.org/drawingml/2006/main" xmlns:r="http://schemas.openxmlformats.org/officeDocument/2006/relationships" xmlns:p="http://schemas.openxmlformats.org/presentationml/2006/main">
+  <p:cSld>
+    <p:spTree>
+      <p:nvGrpSpPr>
+        <p:cNvPr id="1" name=""/>
+        <p:cNvGrpSpPr/>
+        <p:nvPr/>
+      </p:nvGrpSpPr>
+      <p:grpSpPr>
+        <a:xfrm>
+          <a:off x="0" y="0"/>
+          <a:ext cx="0" cy="0"/>
+          <a:chOff x="0" y="0"/>
+          <a:chExt cx="0" cy="0"/>
+        </a:xfrm>
+      </p:grpSpPr>
+      <p:sp>
+        <p:nvSpPr>
+          <p:cNvPr id="2" name="Slide Image Placeholder 1"/>
+          <p:cNvSpPr>
+            <a:spLocks noGrp="1" noRot="1" noChangeAspect="1"/>
+          </p:cNvSpPr>
+          <p:nvPr>
+            <p:ph type="sldImg"/>
+          </p:nvPr>
+        </p:nvSpPr>
+        <p:spPr/>
         <p:txBody>
           <a:bodyPr/>
           <a:lstStyle/>
@@ -4102,7 +4191,7 @@
 </p:notes>
 </file>
 
-<file path=ppt/notesSlides/notesSlide2.xml><?xml version="1.0" encoding="utf-8"?>
+<file path=ppt/notesSlides/notesSlide3.xml><?xml version="1.0" encoding="utf-8"?>
 <p:notes xmlns:a="http://schemas.openxmlformats.org/drawingml/2006/main" xmlns:r="http://schemas.openxmlformats.org/officeDocument/2006/relationships" xmlns:p="http://schemas.openxmlformats.org/presentationml/2006/main">
   <p:cSld>
     <p:spTree>
@@ -4220,116 +4309,6 @@
 </p:notes>
 </file>
 
-<file path=ppt/notesSlides/notesSlide3.xml><?xml version="1.0" encoding="utf-8"?>
-<p:notes xmlns:a="http://schemas.openxmlformats.org/drawingml/2006/main" xmlns:r="http://schemas.openxmlformats.org/officeDocument/2006/relationships" xmlns:p="http://schemas.openxmlformats.org/presentationml/2006/main">
-  <p:cSld>
-    <p:spTree>
-      <p:nvGrpSpPr>
-        <p:cNvPr id="1" name=""/>
-        <p:cNvGrpSpPr/>
-        <p:nvPr/>
-      </p:nvGrpSpPr>
-      <p:grpSpPr>
-        <a:xfrm>
-          <a:off x="0" y="0"/>
-          <a:ext cx="0" cy="0"/>
-          <a:chOff x="0" y="0"/>
-          <a:chExt cx="0" cy="0"/>
-        </a:xfrm>
-      </p:grpSpPr>
-      <p:sp>
-        <p:nvSpPr>
-          <p:cNvPr id="2" name="Slide Image Placeholder 1"/>
-          <p:cNvSpPr>
-            <a:spLocks noGrp="1" noRot="1" noChangeAspect="1"/>
-          </p:cNvSpPr>
-          <p:nvPr>
-            <p:ph type="sldImg"/>
-          </p:nvPr>
-        </p:nvSpPr>
-        <p:spPr/>
-        <p:txBody>
-          <a:bodyPr/>
-          <a:lstStyle/>
-          <a:p>
-            <a:endParaRPr lang="en-CH"/>
-          </a:p>
-        </p:txBody>
-      </p:sp>
-      <p:sp>
-        <p:nvSpPr>
-          <p:cNvPr id="3" name="Notes Placeholder 2"/>
-          <p:cNvSpPr>
-            <a:spLocks noGrp="1"/>
-          </p:cNvSpPr>
-          <p:nvPr>
-            <p:ph type="body" idx="1"/>
-          </p:nvPr>
-        </p:nvSpPr>
-        <p:spPr/>
-        <p:txBody>
-          <a:bodyPr/>
-          <a:lstStyle/>
-          <a:p>
-            <a:r>
-              <a:rPr lang="en-CH" dirty="0"/>
-              <a:t>actually, it’s even worse – the </a:t>
-            </a:r>
-            <a:r>
-              <a:rPr lang="en-CH" dirty="0" err="1"/>
-              <a:t>reentrancies</a:t>
-            </a:r>
-            <a:r>
-              <a:rPr lang="en-CH" dirty="0"/>
-              <a:t> are only guarded against if we entered the contract through one of the @nonReentrant </a:t>
-            </a:r>
-            <a:r>
-              <a:rPr lang="en-CH" dirty="0" err="1"/>
-              <a:t>entrypoints</a:t>
-            </a:r>
-            <a:r>
-              <a:rPr lang="en-CH" dirty="0"/>
-              <a:t>. but I’m not sure how to concisely explain that...</a:t>
-            </a:r>
-          </a:p>
-        </p:txBody>
-      </p:sp>
-      <p:sp>
-        <p:nvSpPr>
-          <p:cNvPr id="4" name="Slide Number Placeholder 3"/>
-          <p:cNvSpPr>
-            <a:spLocks noGrp="1"/>
-          </p:cNvSpPr>
-          <p:nvPr>
-            <p:ph type="sldNum" sz="quarter" idx="5"/>
-          </p:nvPr>
-        </p:nvSpPr>
-        <p:spPr/>
-        <p:txBody>
-          <a:bodyPr/>
-          <a:lstStyle/>
-          <a:p>
-            <a:fld id="{ADB26BFD-26FA-41FF-A418-AE5D5C01BD91}" type="slidenum">
-              <a:rPr lang="en-CH" smtClean="0"/>
-              <a:t>21</a:t>
-            </a:fld>
-            <a:endParaRPr lang="en-CH"/>
-          </a:p>
-        </p:txBody>
-      </p:sp>
-    </p:spTree>
-    <p:extLst>
-      <p:ext uri="{BB962C8B-B14F-4D97-AF65-F5344CB8AC3E}">
-        <p14:creationId xmlns:p14="http://schemas.microsoft.com/office/powerpoint/2010/main" val="131999998"/>
-      </p:ext>
-    </p:extLst>
-  </p:cSld>
-  <p:clrMapOvr>
-    <a:masterClrMapping/>
-  </p:clrMapOvr>
-</p:notes>
-</file>
-
 <file path=ppt/notesSlides/notesSlide4.xml><?xml version="1.0" encoding="utf-8"?>
 <p:notes xmlns:a="http://schemas.openxmlformats.org/drawingml/2006/main" xmlns:r="http://schemas.openxmlformats.org/officeDocument/2006/relationships" xmlns:p="http://schemas.openxmlformats.org/presentationml/2006/main">
   <p:cSld>
@@ -4383,7 +4362,23 @@
           <a:p>
             <a:r>
               <a:rPr lang="en-CH" dirty="0"/>
-              <a:t>mention that there are actual cases where order is not left to right</a:t>
+              <a:t>actually, it’s even worse – the </a:t>
+            </a:r>
+            <a:r>
+              <a:rPr lang="en-CH" dirty="0" err="1"/>
+              <a:t>reentrancies</a:t>
+            </a:r>
+            <a:r>
+              <a:rPr lang="en-CH" dirty="0"/>
+              <a:t> are only guarded against if we entered the contract through one of the @nonReentrant </a:t>
+            </a:r>
+            <a:r>
+              <a:rPr lang="en-CH" dirty="0" err="1"/>
+              <a:t>entrypoints</a:t>
+            </a:r>
+            <a:r>
+              <a:rPr lang="en-CH" dirty="0"/>
+              <a:t>. but I’m not sure how to concisely explain that...</a:t>
             </a:r>
           </a:p>
         </p:txBody>
@@ -4405,7 +4400,7 @@
           <a:p>
             <a:fld id="{ADB26BFD-26FA-41FF-A418-AE5D5C01BD91}" type="slidenum">
               <a:rPr lang="en-CH" smtClean="0"/>
-              <a:t>24</a:t>
+              <a:t>21</a:t>
             </a:fld>
             <a:endParaRPr lang="en-CH"/>
           </a:p>
@@ -4414,7 +4409,7 @@
     </p:spTree>
     <p:extLst>
       <p:ext uri="{BB962C8B-B14F-4D97-AF65-F5344CB8AC3E}">
-        <p14:creationId xmlns:p14="http://schemas.microsoft.com/office/powerpoint/2010/main" val="4148305803"/>
+        <p14:creationId xmlns:p14="http://schemas.microsoft.com/office/powerpoint/2010/main" val="131999998"/>
       </p:ext>
     </p:extLst>
   </p:cSld>
@@ -4475,7 +4470,10 @@
           <a:bodyPr/>
           <a:lstStyle/>
           <a:p>
-            <a:endParaRPr lang="en-CH" dirty="0"/>
+            <a:r>
+              <a:rPr lang="en-CH" dirty="0"/>
+              <a:t>mention that there are actual cases where order is not left to right</a:t>
+            </a:r>
           </a:p>
         </p:txBody>
       </p:sp>
@@ -4496,7 +4494,98 @@
           <a:p>
             <a:fld id="{ADB26BFD-26FA-41FF-A418-AE5D5C01BD91}" type="slidenum">
               <a:rPr lang="en-CH" smtClean="0"/>
-              <a:t>48</a:t>
+              <a:t>24</a:t>
+            </a:fld>
+            <a:endParaRPr lang="en-CH"/>
+          </a:p>
+        </p:txBody>
+      </p:sp>
+    </p:spTree>
+    <p:extLst>
+      <p:ext uri="{BB962C8B-B14F-4D97-AF65-F5344CB8AC3E}">
+        <p14:creationId xmlns:p14="http://schemas.microsoft.com/office/powerpoint/2010/main" val="4148305803"/>
+      </p:ext>
+    </p:extLst>
+  </p:cSld>
+  <p:clrMapOvr>
+    <a:masterClrMapping/>
+  </p:clrMapOvr>
+</p:notes>
+</file>
+
+<file path=ppt/notesSlides/notesSlide6.xml><?xml version="1.0" encoding="utf-8"?>
+<p:notes xmlns:a="http://schemas.openxmlformats.org/drawingml/2006/main" xmlns:r="http://schemas.openxmlformats.org/officeDocument/2006/relationships" xmlns:p="http://schemas.openxmlformats.org/presentationml/2006/main">
+  <p:cSld>
+    <p:spTree>
+      <p:nvGrpSpPr>
+        <p:cNvPr id="1" name=""/>
+        <p:cNvGrpSpPr/>
+        <p:nvPr/>
+      </p:nvGrpSpPr>
+      <p:grpSpPr>
+        <a:xfrm>
+          <a:off x="0" y="0"/>
+          <a:ext cx="0" cy="0"/>
+          <a:chOff x="0" y="0"/>
+          <a:chExt cx="0" cy="0"/>
+        </a:xfrm>
+      </p:grpSpPr>
+      <p:sp>
+        <p:nvSpPr>
+          <p:cNvPr id="2" name="Slide Image Placeholder 1"/>
+          <p:cNvSpPr>
+            <a:spLocks noGrp="1" noRot="1" noChangeAspect="1"/>
+          </p:cNvSpPr>
+          <p:nvPr>
+            <p:ph type="sldImg"/>
+          </p:nvPr>
+        </p:nvSpPr>
+        <p:spPr/>
+        <p:txBody>
+          <a:bodyPr/>
+          <a:lstStyle/>
+          <a:p>
+            <a:endParaRPr lang="en-CH"/>
+          </a:p>
+        </p:txBody>
+      </p:sp>
+      <p:sp>
+        <p:nvSpPr>
+          <p:cNvPr id="3" name="Notes Placeholder 2"/>
+          <p:cNvSpPr>
+            <a:spLocks noGrp="1"/>
+          </p:cNvSpPr>
+          <p:nvPr>
+            <p:ph type="body" idx="1"/>
+          </p:nvPr>
+        </p:nvSpPr>
+        <p:spPr/>
+        <p:txBody>
+          <a:bodyPr/>
+          <a:lstStyle/>
+          <a:p>
+            <a:endParaRPr lang="en-CH" dirty="0"/>
+          </a:p>
+        </p:txBody>
+      </p:sp>
+      <p:sp>
+        <p:nvSpPr>
+          <p:cNvPr id="4" name="Slide Number Placeholder 3"/>
+          <p:cNvSpPr>
+            <a:spLocks noGrp="1"/>
+          </p:cNvSpPr>
+          <p:nvPr>
+            <p:ph type="sldNum" sz="quarter" idx="5"/>
+          </p:nvPr>
+        </p:nvSpPr>
+        <p:spPr/>
+        <p:txBody>
+          <a:bodyPr/>
+          <a:lstStyle/>
+          <a:p>
+            <a:fld id="{ADB26BFD-26FA-41FF-A418-AE5D5C01BD91}" type="slidenum">
+              <a:rPr lang="en-CH" smtClean="0"/>
+              <a:t>49</a:t>
             </a:fld>
             <a:endParaRPr lang="en-CH"/>
           </a:p>
@@ -10696,7 +10785,15 @@
             <a:pPr lvl="2"/>
             <a:r>
               <a:rPr lang="en-CH" dirty="0"/>
-              <a:t>expensive, &gt;2000$ per auditor per day</a:t>
+              <a:t>Expensive </a:t>
+            </a:r>
+            <a:r>
+              <a:rPr lang="en-CH" dirty="0">
+                <a:solidFill>
+                  <a:schemeClr val="tx2"/>
+                </a:solidFill>
+              </a:rPr>
+              <a:t>(&gt;2000$ per auditor per day)</a:t>
             </a:r>
           </a:p>
           <a:p>
@@ -10925,7 +11022,7 @@
           <a:p>
             <a:r>
               <a:rPr lang="en-CH" dirty="0"/>
-              <a:t>Common Vulnerabilities</a:t>
+              <a:t>Common Vulnerabilities (2021-2024)</a:t>
             </a:r>
           </a:p>
         </p:txBody>
@@ -11349,7 +11446,7 @@
                   <a:schemeClr val="tx2"/>
                 </a:solidFill>
               </a:rPr>
-              <a:t>Common Vulnerabilities</a:t>
+              <a:t>Common Vulnerabilities (2021-2024)</a:t>
             </a:r>
           </a:p>
         </p:txBody>
@@ -18015,7 +18112,15 @@
           <a:p>
             <a:r>
               <a:rPr lang="en-GB" dirty="0"/>
-              <a:t>First appearance: June 17, 2016</a:t>
+              <a:t>First </a:t>
+            </a:r>
+            <a:r>
+              <a:rPr lang="en-CH" dirty="0"/>
+              <a:t>occurrence</a:t>
+            </a:r>
+            <a:r>
+              <a:rPr lang="en-GB" dirty="0"/>
+              <a:t>: June 17, 2016</a:t>
             </a:r>
           </a:p>
           <a:p>
@@ -18272,8 +18377,12 @@
           <a:p>
             <a:pPr lvl="1"/>
             <a:r>
+              <a:rPr lang="en-CH" dirty="0"/>
+              <a:t>There is no</a:t>
+            </a:r>
+            <a:r>
               <a:rPr lang="en-GB" dirty="0"/>
-              <a:t>No “safety by default”</a:t>
+              <a:t> “safety by default”</a:t>
             </a:r>
           </a:p>
           <a:p>
@@ -18281,8 +18390,12 @@
           </a:p>
           <a:p>
             <a:r>
+              <a:rPr lang="en-CH" dirty="0"/>
+              <a:t>But w</a:t>
+            </a:r>
+            <a:r>
               <a:rPr lang="en-GB" dirty="0"/>
-              <a:t>But when they do…</a:t>
+              <a:t>hen they do…</a:t>
             </a:r>
           </a:p>
           <a:p>
@@ -42442,7 +42555,7 @@
           <a:p>
             <a:r>
               <a:rPr lang="en-CH" dirty="0"/>
-              <a:t>The “blockchain” is not relevant for us</a:t>
+              <a:t>The “blockchain” part is not relevant for us</a:t>
             </a:r>
           </a:p>
           <a:p>
@@ -42461,7 +42574,7 @@
           <a:p>
             <a:r>
               <a:rPr lang="en-CH" dirty="0"/>
-              <a:t>“State”: hash map Address </a:t>
+              <a:t>“State”: Hash Map  Address </a:t>
             </a:r>
             <a:r>
               <a:rPr lang="en-CH" dirty="0">
@@ -42516,7 +42629,7 @@
             <a:pPr lvl="1"/>
             <a:r>
               <a:rPr lang="en-CH" dirty="0"/>
-              <a:t>Smart Contract: Program, may be executed by transactions</a:t>
+              <a:t>Smart Contract: “Program”, may be executed by transactions</a:t>
             </a:r>
           </a:p>
           <a:p>
@@ -43214,7 +43327,7 @@
 </file>
 
 <file path=ppt/slides/slide42.xml><?xml version="1.0" encoding="utf-8"?>
-<p:sld xmlns:a="http://schemas.openxmlformats.org/drawingml/2006/main" xmlns:r="http://schemas.openxmlformats.org/officeDocument/2006/relationships" xmlns:p="http://schemas.openxmlformats.org/presentationml/2006/main">
+<p:sld xmlns:a="http://schemas.openxmlformats.org/drawingml/2006/main" xmlns:r="http://schemas.openxmlformats.org/officeDocument/2006/relationships" xmlns:p="http://schemas.openxmlformats.org/presentationml/2006/main" show="0">
   <p:cSld>
     <p:spTree>
       <p:nvGrpSpPr>
@@ -43412,6 +43525,185 @@
 </file>
 
 <file path=ppt/slides/slide43.xml><?xml version="1.0" encoding="utf-8"?>
+<p:sld xmlns:a="http://schemas.openxmlformats.org/drawingml/2006/main" xmlns:r="http://schemas.openxmlformats.org/officeDocument/2006/relationships" xmlns:p="http://schemas.openxmlformats.org/presentationml/2006/main">
+  <p:cSld>
+    <p:spTree>
+      <p:nvGrpSpPr>
+        <p:cNvPr id="1" name=""/>
+        <p:cNvGrpSpPr/>
+        <p:nvPr/>
+      </p:nvGrpSpPr>
+      <p:grpSpPr>
+        <a:xfrm>
+          <a:off x="0" y="0"/>
+          <a:ext cx="0" cy="0"/>
+          <a:chOff x="0" y="0"/>
+          <a:chExt cx="0" cy="0"/>
+        </a:xfrm>
+      </p:grpSpPr>
+      <p:sp>
+        <p:nvSpPr>
+          <p:cNvPr id="2" name="Title 1">
+            <a:extLst>
+              <a:ext uri="{FF2B5EF4-FFF2-40B4-BE49-F238E27FC236}">
+                <a16:creationId xmlns:a16="http://schemas.microsoft.com/office/drawing/2014/main" id="{F8842AB2-2ADC-F734-0542-7602AB1E0E68}"/>
+              </a:ext>
+            </a:extLst>
+          </p:cNvPr>
+          <p:cNvSpPr>
+            <a:spLocks noGrp="1"/>
+          </p:cNvSpPr>
+          <p:nvPr>
+            <p:ph type="title"/>
+          </p:nvPr>
+        </p:nvSpPr>
+        <p:spPr/>
+        <p:txBody>
+          <a:bodyPr/>
+          <a:lstStyle/>
+          <a:p>
+            <a:r>
+              <a:rPr lang="en-CH" dirty="0"/>
+              <a:t>Q&amp;A</a:t>
+            </a:r>
+          </a:p>
+        </p:txBody>
+      </p:sp>
+      <p:sp>
+        <p:nvSpPr>
+          <p:cNvPr id="3" name="Content Placeholder 2">
+            <a:extLst>
+              <a:ext uri="{FF2B5EF4-FFF2-40B4-BE49-F238E27FC236}">
+                <a16:creationId xmlns:a16="http://schemas.microsoft.com/office/drawing/2014/main" id="{9D11AF25-A2E8-B876-B465-B0D8781F2AF8}"/>
+              </a:ext>
+            </a:extLst>
+          </p:cNvPr>
+          <p:cNvSpPr>
+            <a:spLocks noGrp="1"/>
+          </p:cNvSpPr>
+          <p:nvPr>
+            <p:ph idx="1"/>
+          </p:nvPr>
+        </p:nvSpPr>
+        <p:spPr/>
+        <p:txBody>
+          <a:bodyPr/>
+          <a:lstStyle/>
+          <a:p>
+            <a:endParaRPr lang="en-CH"/>
+          </a:p>
+        </p:txBody>
+      </p:sp>
+      <p:sp>
+        <p:nvSpPr>
+          <p:cNvPr id="4" name="Date Placeholder 3">
+            <a:extLst>
+              <a:ext uri="{FF2B5EF4-FFF2-40B4-BE49-F238E27FC236}">
+                <a16:creationId xmlns:a16="http://schemas.microsoft.com/office/drawing/2014/main" id="{AC25CF91-966D-8DA4-7E89-E83949178788}"/>
+              </a:ext>
+            </a:extLst>
+          </p:cNvPr>
+          <p:cNvSpPr>
+            <a:spLocks noGrp="1"/>
+          </p:cNvSpPr>
+          <p:nvPr>
+            <p:ph type="dt" sz="half" idx="10"/>
+          </p:nvPr>
+        </p:nvSpPr>
+        <p:spPr/>
+        <p:txBody>
+          <a:bodyPr/>
+          <a:lstStyle/>
+          <a:p>
+            <a:r>
+              <a:rPr lang="en-CH"/>
+              <a:t>30/03/2026</a:t>
+            </a:r>
+            <a:endParaRPr lang="en-CH" dirty="0"/>
+          </a:p>
+        </p:txBody>
+      </p:sp>
+      <p:sp>
+        <p:nvSpPr>
+          <p:cNvPr id="5" name="Footer Placeholder 4">
+            <a:extLst>
+              <a:ext uri="{FF2B5EF4-FFF2-40B4-BE49-F238E27FC236}">
+                <a16:creationId xmlns:a16="http://schemas.microsoft.com/office/drawing/2014/main" id="{FB4062E1-FC84-D62B-00E2-D6660204035F}"/>
+              </a:ext>
+            </a:extLst>
+          </p:cNvPr>
+          <p:cNvSpPr>
+            <a:spLocks noGrp="1"/>
+          </p:cNvSpPr>
+          <p:nvPr>
+            <p:ph type="ftr" sz="quarter" idx="11"/>
+          </p:nvPr>
+        </p:nvSpPr>
+        <p:spPr/>
+        <p:txBody>
+          <a:bodyPr/>
+          <a:lstStyle/>
+          <a:p>
+            <a:r>
+              <a:rPr lang="en-CH"/>
+              <a:t>Eliminating Reentrancy through Language Design</a:t>
+            </a:r>
+            <a:endParaRPr lang="en-CH" dirty="0">
+              <a:solidFill>
+                <a:schemeClr val="tx2"/>
+              </a:solidFill>
+            </a:endParaRPr>
+          </a:p>
+        </p:txBody>
+      </p:sp>
+      <p:sp>
+        <p:nvSpPr>
+          <p:cNvPr id="6" name="Slide Number Placeholder 5">
+            <a:extLst>
+              <a:ext uri="{FF2B5EF4-FFF2-40B4-BE49-F238E27FC236}">
+                <a16:creationId xmlns:a16="http://schemas.microsoft.com/office/drawing/2014/main" id="{F544F9FC-F5DA-F0F7-3A75-E922447E77A6}"/>
+              </a:ext>
+            </a:extLst>
+          </p:cNvPr>
+          <p:cNvSpPr>
+            <a:spLocks noGrp="1"/>
+          </p:cNvSpPr>
+          <p:nvPr>
+            <p:ph type="sldNum" sz="quarter" idx="12"/>
+          </p:nvPr>
+        </p:nvSpPr>
+        <p:spPr/>
+        <p:txBody>
+          <a:bodyPr/>
+          <a:lstStyle/>
+          <a:p>
+            <a:fld id="{1013ED95-016C-42D7-B550-5C99AA40E4D5}" type="slidenum">
+              <a:rPr lang="en-CH" smtClean="0"/>
+              <a:pPr/>
+              <a:t>43</a:t>
+            </a:fld>
+            <a:r>
+              <a:rPr lang="en-CH"/>
+              <a:t> / XX</a:t>
+            </a:r>
+            <a:endParaRPr lang="en-CH" dirty="0"/>
+          </a:p>
+        </p:txBody>
+      </p:sp>
+    </p:spTree>
+    <p:extLst>
+      <p:ext uri="{BB962C8B-B14F-4D97-AF65-F5344CB8AC3E}">
+        <p14:creationId xmlns:p14="http://schemas.microsoft.com/office/powerpoint/2010/main" val="2083579794"/>
+      </p:ext>
+    </p:extLst>
+  </p:cSld>
+  <p:clrMapOvr>
+    <a:masterClrMapping/>
+  </p:clrMapOvr>
+</p:sld>
+</file>
+
+<file path=ppt/slides/slide44.xml><?xml version="1.0" encoding="utf-8"?>
 <p:sld xmlns:a="http://schemas.openxmlformats.org/drawingml/2006/main" xmlns:r="http://schemas.openxmlformats.org/officeDocument/2006/relationships" xmlns:p="http://schemas.openxmlformats.org/presentationml/2006/main" show="0">
   <p:cSld>
     <p:spTree>
@@ -43586,7 +43878,7 @@
             <a:fld id="{1013ED95-016C-42D7-B550-5C99AA40E4D5}" type="slidenum">
               <a:rPr lang="en-CH" smtClean="0"/>
               <a:pPr/>
-              <a:t>43</a:t>
+              <a:t>44</a:t>
             </a:fld>
             <a:r>
               <a:rPr lang="en-CH"/>
@@ -43609,7 +43901,7 @@
 </p:sld>
 </file>
 
-<file path=ppt/slides/slide44.xml><?xml version="1.0" encoding="utf-8"?>
+<file path=ppt/slides/slide45.xml><?xml version="1.0" encoding="utf-8"?>
 <p:sld xmlns:a="http://schemas.openxmlformats.org/drawingml/2006/main" xmlns:r="http://schemas.openxmlformats.org/officeDocument/2006/relationships" xmlns:p="http://schemas.openxmlformats.org/presentationml/2006/main">
   <p:cSld>
     <p:spTree>
@@ -45556,7 +45848,7 @@
             <a:fld id="{1013ED95-016C-42D7-B550-5C99AA40E4D5}" type="slidenum">
               <a:rPr lang="en-CH" smtClean="0"/>
               <a:pPr/>
-              <a:t>44</a:t>
+              <a:t>45</a:t>
             </a:fld>
             <a:r>
               <a:rPr lang="en-CH"/>
@@ -45579,7 +45871,7 @@
 </p:sld>
 </file>
 
-<file path=ppt/slides/slide45.xml><?xml version="1.0" encoding="utf-8"?>
+<file path=ppt/slides/slide46.xml><?xml version="1.0" encoding="utf-8"?>
 <p:sld xmlns:a="http://schemas.openxmlformats.org/drawingml/2006/main" xmlns:r="http://schemas.openxmlformats.org/officeDocument/2006/relationships" xmlns:p="http://schemas.openxmlformats.org/presentationml/2006/main">
   <p:cSld>
     <p:spTree>
@@ -47526,7 +47818,7 @@
             <a:fld id="{1013ED95-016C-42D7-B550-5C99AA40E4D5}" type="slidenum">
               <a:rPr lang="en-CH" smtClean="0"/>
               <a:pPr/>
-              <a:t>45</a:t>
+              <a:t>46</a:t>
             </a:fld>
             <a:r>
               <a:rPr lang="en-CH"/>
@@ -47549,7 +47841,7 @@
 </p:sld>
 </file>
 
-<file path=ppt/slides/slide46.xml><?xml version="1.0" encoding="utf-8"?>
+<file path=ppt/slides/slide47.xml><?xml version="1.0" encoding="utf-8"?>
 <p:sld xmlns:a="http://schemas.openxmlformats.org/drawingml/2006/main" xmlns:r="http://schemas.openxmlformats.org/officeDocument/2006/relationships" xmlns:p="http://schemas.openxmlformats.org/presentationml/2006/main" show="0">
   <p:cSld>
     <p:spTree>
@@ -47718,7 +48010,7 @@
             <a:fld id="{1013ED95-016C-42D7-B550-5C99AA40E4D5}" type="slidenum">
               <a:rPr lang="en-CH" smtClean="0"/>
               <a:pPr/>
-              <a:t>46</a:t>
+              <a:t>47</a:t>
             </a:fld>
             <a:r>
               <a:rPr lang="en-CH"/>
@@ -47741,7 +48033,7 @@
 </p:sld>
 </file>
 
-<file path=ppt/slides/slide47.xml><?xml version="1.0" encoding="utf-8"?>
+<file path=ppt/slides/slide48.xml><?xml version="1.0" encoding="utf-8"?>
 <p:sld xmlns:a="http://schemas.openxmlformats.org/drawingml/2006/main" xmlns:r="http://schemas.openxmlformats.org/officeDocument/2006/relationships" xmlns:p="http://schemas.openxmlformats.org/presentationml/2006/main">
   <p:cSld>
     <p:spTree>
@@ -48607,7 +48899,7 @@
             <a:fld id="{1013ED95-016C-42D7-B550-5C99AA40E4D5}" type="slidenum">
               <a:rPr lang="en-CH" smtClean="0"/>
               <a:pPr/>
-              <a:t>47</a:t>
+              <a:t>48</a:t>
             </a:fld>
             <a:r>
               <a:rPr lang="en-CH"/>
@@ -48673,7 +48965,7 @@
 </p:sld>
 </file>
 
-<file path=ppt/slides/slide48.xml><?xml version="1.0" encoding="utf-8"?>
+<file path=ppt/slides/slide49.xml><?xml version="1.0" encoding="utf-8"?>
 <p:sld xmlns:a="http://schemas.openxmlformats.org/drawingml/2006/main" xmlns:r="http://schemas.openxmlformats.org/officeDocument/2006/relationships" xmlns:p="http://schemas.openxmlformats.org/presentationml/2006/main">
   <p:cSld>
     <p:spTree>
@@ -50107,7 +50399,7 @@
             <a:fld id="{1013ED95-016C-42D7-B550-5C99AA40E4D5}" type="slidenum">
               <a:rPr lang="en-CH" smtClean="0"/>
               <a:pPr/>
-              <a:t>48</a:t>
+              <a:t>49</a:t>
             </a:fld>
             <a:r>
               <a:rPr lang="en-CH"/>
@@ -50692,249 +50984,6 @@
 </p:sld>
 </file>
 
-<file path=ppt/slides/slide49.xml><?xml version="1.0" encoding="utf-8"?>
-<p:sld xmlns:a="http://schemas.openxmlformats.org/drawingml/2006/main" xmlns:r="http://schemas.openxmlformats.org/officeDocument/2006/relationships" xmlns:p="http://schemas.openxmlformats.org/presentationml/2006/main">
-  <p:cSld>
-    <p:spTree>
-      <p:nvGrpSpPr>
-        <p:cNvPr id="1" name=""/>
-        <p:cNvGrpSpPr/>
-        <p:nvPr/>
-      </p:nvGrpSpPr>
-      <p:grpSpPr>
-        <a:xfrm>
-          <a:off x="0" y="0"/>
-          <a:ext cx="0" cy="0"/>
-          <a:chOff x="0" y="0"/>
-          <a:chExt cx="0" cy="0"/>
-        </a:xfrm>
-      </p:grpSpPr>
-      <p:sp>
-        <p:nvSpPr>
-          <p:cNvPr id="2" name="Title 1">
-            <a:extLst>
-              <a:ext uri="{FF2B5EF4-FFF2-40B4-BE49-F238E27FC236}">
-                <a16:creationId xmlns:a16="http://schemas.microsoft.com/office/drawing/2014/main" id="{4E71206B-7346-72AF-4514-E2F5B0E0723A}"/>
-              </a:ext>
-            </a:extLst>
-          </p:cNvPr>
-          <p:cNvSpPr>
-            <a:spLocks noGrp="1"/>
-          </p:cNvSpPr>
-          <p:nvPr>
-            <p:ph type="title"/>
-          </p:nvPr>
-        </p:nvSpPr>
-        <p:spPr/>
-        <p:txBody>
-          <a:bodyPr/>
-          <a:lstStyle/>
-          <a:p>
-            <a:r>
-              <a:rPr lang="en-CH" dirty="0"/>
-              <a:t>Future Work: Tooling</a:t>
-            </a:r>
-          </a:p>
-        </p:txBody>
-      </p:sp>
-      <p:sp>
-        <p:nvSpPr>
-          <p:cNvPr id="3" name="Content Placeholder 2">
-            <a:extLst>
-              <a:ext uri="{FF2B5EF4-FFF2-40B4-BE49-F238E27FC236}">
-                <a16:creationId xmlns:a16="http://schemas.microsoft.com/office/drawing/2014/main" id="{85B406FC-A085-DB12-6D86-EB47A829326C}"/>
-              </a:ext>
-            </a:extLst>
-          </p:cNvPr>
-          <p:cNvSpPr>
-            <a:spLocks noGrp="1"/>
-          </p:cNvSpPr>
-          <p:nvPr>
-            <p:ph sz="half" idx="1"/>
-          </p:nvPr>
-        </p:nvSpPr>
-        <p:spPr/>
-        <p:txBody>
-          <a:bodyPr/>
-          <a:lstStyle/>
-          <a:p>
-            <a:r>
-              <a:rPr lang="en-CH" dirty="0"/>
-              <a:t>Interpreter:</a:t>
-            </a:r>
-          </a:p>
-          <a:p>
-            <a:pPr lvl="1"/>
-            <a:r>
-              <a:rPr lang="en-CH" dirty="0"/>
-              <a:t>Testing tools deploy mock blockchain, simulate full VM execution</a:t>
-            </a:r>
-          </a:p>
-          <a:p>
-            <a:pPr lvl="2">
-              <a:buFont typeface="Aptos" panose="020B0004020202020204" pitchFamily="34" charset="0"/>
-              <a:buChar char="→"/>
-            </a:pPr>
-            <a:r>
-              <a:rPr lang="en-CH" dirty="0"/>
-              <a:t>huge overhead, bad performance</a:t>
-            </a:r>
-          </a:p>
-          <a:p>
-            <a:pPr lvl="2">
-              <a:buFont typeface="Aptos" panose="020B0004020202020204" pitchFamily="34" charset="0"/>
-              <a:buChar char="→"/>
-            </a:pPr>
-            <a:r>
-              <a:rPr lang="en-CH" dirty="0"/>
-              <a:t>debugging tools are not great</a:t>
-            </a:r>
-          </a:p>
-          <a:p>
-            <a:pPr lvl="1"/>
-            <a:r>
-              <a:rPr lang="en-CH" dirty="0"/>
-              <a:t>Performance greatly impacts fuzz testing</a:t>
-            </a:r>
-          </a:p>
-          <a:p>
-            <a:pPr lvl="1"/>
-            <a:r>
-              <a:rPr lang="en-CH" dirty="0"/>
-              <a:t>Unit tests, step-by-step debugging for internal functions</a:t>
-            </a:r>
-          </a:p>
-        </p:txBody>
-      </p:sp>
-      <p:sp>
-        <p:nvSpPr>
-          <p:cNvPr id="4" name="Content Placeholder 3">
-            <a:extLst>
-              <a:ext uri="{FF2B5EF4-FFF2-40B4-BE49-F238E27FC236}">
-                <a16:creationId xmlns:a16="http://schemas.microsoft.com/office/drawing/2014/main" id="{F58841C8-1090-73BD-8612-E494B8001B15}"/>
-              </a:ext>
-            </a:extLst>
-          </p:cNvPr>
-          <p:cNvSpPr>
-            <a:spLocks noGrp="1"/>
-          </p:cNvSpPr>
-          <p:nvPr>
-            <p:ph sz="half" idx="2"/>
-          </p:nvPr>
-        </p:nvSpPr>
-        <p:spPr/>
-        <p:txBody>
-          <a:bodyPr/>
-          <a:lstStyle/>
-          <a:p>
-            <a:endParaRPr lang="en-CH"/>
-          </a:p>
-        </p:txBody>
-      </p:sp>
-      <p:sp>
-        <p:nvSpPr>
-          <p:cNvPr id="5" name="Date Placeholder 4">
-            <a:extLst>
-              <a:ext uri="{FF2B5EF4-FFF2-40B4-BE49-F238E27FC236}">
-                <a16:creationId xmlns:a16="http://schemas.microsoft.com/office/drawing/2014/main" id="{3EEC5EDA-4793-93D4-A820-F643F2D6FDF9}"/>
-              </a:ext>
-            </a:extLst>
-          </p:cNvPr>
-          <p:cNvSpPr>
-            <a:spLocks noGrp="1"/>
-          </p:cNvSpPr>
-          <p:nvPr>
-            <p:ph type="dt" sz="half" idx="10"/>
-          </p:nvPr>
-        </p:nvSpPr>
-        <p:spPr/>
-        <p:txBody>
-          <a:bodyPr/>
-          <a:lstStyle/>
-          <a:p>
-            <a:r>
-              <a:rPr lang="en-CH"/>
-              <a:t>30/03/2026</a:t>
-            </a:r>
-          </a:p>
-        </p:txBody>
-      </p:sp>
-      <p:sp>
-        <p:nvSpPr>
-          <p:cNvPr id="6" name="Footer Placeholder 5">
-            <a:extLst>
-              <a:ext uri="{FF2B5EF4-FFF2-40B4-BE49-F238E27FC236}">
-                <a16:creationId xmlns:a16="http://schemas.microsoft.com/office/drawing/2014/main" id="{DF860437-8E73-31B9-4ABA-36AA6E6E72AD}"/>
-              </a:ext>
-            </a:extLst>
-          </p:cNvPr>
-          <p:cNvSpPr>
-            <a:spLocks noGrp="1"/>
-          </p:cNvSpPr>
-          <p:nvPr>
-            <p:ph type="ftr" sz="quarter" idx="11"/>
-          </p:nvPr>
-        </p:nvSpPr>
-        <p:spPr/>
-        <p:txBody>
-          <a:bodyPr/>
-          <a:lstStyle/>
-          <a:p>
-            <a:r>
-              <a:rPr lang="en-US"/>
-              <a:t>Eliminating Reentrancy through Language Design</a:t>
-            </a:r>
-            <a:endParaRPr lang="en-CH"/>
-          </a:p>
-        </p:txBody>
-      </p:sp>
-      <p:sp>
-        <p:nvSpPr>
-          <p:cNvPr id="7" name="Slide Number Placeholder 6">
-            <a:extLst>
-              <a:ext uri="{FF2B5EF4-FFF2-40B4-BE49-F238E27FC236}">
-                <a16:creationId xmlns:a16="http://schemas.microsoft.com/office/drawing/2014/main" id="{D8C406F5-71EE-FBE8-90CF-182F580B400A}"/>
-              </a:ext>
-            </a:extLst>
-          </p:cNvPr>
-          <p:cNvSpPr>
-            <a:spLocks noGrp="1"/>
-          </p:cNvSpPr>
-          <p:nvPr>
-            <p:ph type="sldNum" sz="quarter" idx="12"/>
-          </p:nvPr>
-        </p:nvSpPr>
-        <p:spPr/>
-        <p:txBody>
-          <a:bodyPr/>
-          <a:lstStyle/>
-          <a:p>
-            <a:fld id="{1013ED95-016C-42D7-B550-5C99AA40E4D5}" type="slidenum">
-              <a:rPr lang="en-CH" smtClean="0"/>
-              <a:pPr/>
-              <a:t>49</a:t>
-            </a:fld>
-            <a:r>
-              <a:rPr lang="en-CH"/>
-              <a:t> / XX</a:t>
-            </a:r>
-            <a:endParaRPr lang="en-CH" dirty="0"/>
-          </a:p>
-        </p:txBody>
-      </p:sp>
-    </p:spTree>
-    <p:extLst>
-      <p:ext uri="{BB962C8B-B14F-4D97-AF65-F5344CB8AC3E}">
-        <p14:creationId xmlns:p14="http://schemas.microsoft.com/office/powerpoint/2010/main" val="101902366"/>
-      </p:ext>
-    </p:extLst>
-  </p:cSld>
-  <p:clrMapOvr>
-    <a:masterClrMapping/>
-  </p:clrMapOvr>
-</p:sld>
-</file>
-
 <file path=ppt/slides/slide5.xml><?xml version="1.0" encoding="utf-8"?>
 <p:sld xmlns:a="http://schemas.openxmlformats.org/drawingml/2006/main" xmlns:r="http://schemas.openxmlformats.org/officeDocument/2006/relationships" xmlns:p="http://schemas.openxmlformats.org/presentationml/2006/main">
   <p:cSld>
@@ -51048,7 +51097,7 @@
             </a:r>
             <a:r>
               <a:rPr lang="en-CH" dirty="0"/>
-              <a:t> uint256 hash map)</a:t>
+              <a:t> uint256 Hash Map)</a:t>
             </a:r>
           </a:p>
           <a:p>
@@ -51186,6 +51235,249 @@
 </file>
 
 <file path=ppt/slides/slide50.xml><?xml version="1.0" encoding="utf-8"?>
+<p:sld xmlns:a="http://schemas.openxmlformats.org/drawingml/2006/main" xmlns:r="http://schemas.openxmlformats.org/officeDocument/2006/relationships" xmlns:p="http://schemas.openxmlformats.org/presentationml/2006/main">
+  <p:cSld>
+    <p:spTree>
+      <p:nvGrpSpPr>
+        <p:cNvPr id="1" name=""/>
+        <p:cNvGrpSpPr/>
+        <p:nvPr/>
+      </p:nvGrpSpPr>
+      <p:grpSpPr>
+        <a:xfrm>
+          <a:off x="0" y="0"/>
+          <a:ext cx="0" cy="0"/>
+          <a:chOff x="0" y="0"/>
+          <a:chExt cx="0" cy="0"/>
+        </a:xfrm>
+      </p:grpSpPr>
+      <p:sp>
+        <p:nvSpPr>
+          <p:cNvPr id="2" name="Title 1">
+            <a:extLst>
+              <a:ext uri="{FF2B5EF4-FFF2-40B4-BE49-F238E27FC236}">
+                <a16:creationId xmlns:a16="http://schemas.microsoft.com/office/drawing/2014/main" id="{4E71206B-7346-72AF-4514-E2F5B0E0723A}"/>
+              </a:ext>
+            </a:extLst>
+          </p:cNvPr>
+          <p:cNvSpPr>
+            <a:spLocks noGrp="1"/>
+          </p:cNvSpPr>
+          <p:nvPr>
+            <p:ph type="title"/>
+          </p:nvPr>
+        </p:nvSpPr>
+        <p:spPr/>
+        <p:txBody>
+          <a:bodyPr/>
+          <a:lstStyle/>
+          <a:p>
+            <a:r>
+              <a:rPr lang="en-CH" dirty="0"/>
+              <a:t>Future Work: Tooling</a:t>
+            </a:r>
+          </a:p>
+        </p:txBody>
+      </p:sp>
+      <p:sp>
+        <p:nvSpPr>
+          <p:cNvPr id="3" name="Content Placeholder 2">
+            <a:extLst>
+              <a:ext uri="{FF2B5EF4-FFF2-40B4-BE49-F238E27FC236}">
+                <a16:creationId xmlns:a16="http://schemas.microsoft.com/office/drawing/2014/main" id="{85B406FC-A085-DB12-6D86-EB47A829326C}"/>
+              </a:ext>
+            </a:extLst>
+          </p:cNvPr>
+          <p:cNvSpPr>
+            <a:spLocks noGrp="1"/>
+          </p:cNvSpPr>
+          <p:nvPr>
+            <p:ph sz="half" idx="1"/>
+          </p:nvPr>
+        </p:nvSpPr>
+        <p:spPr/>
+        <p:txBody>
+          <a:bodyPr/>
+          <a:lstStyle/>
+          <a:p>
+            <a:r>
+              <a:rPr lang="en-CH" dirty="0"/>
+              <a:t>Interpreter:</a:t>
+            </a:r>
+          </a:p>
+          <a:p>
+            <a:pPr lvl="1"/>
+            <a:r>
+              <a:rPr lang="en-CH" dirty="0"/>
+              <a:t>Testing tools deploy mock blockchain, simulate full VM execution</a:t>
+            </a:r>
+          </a:p>
+          <a:p>
+            <a:pPr lvl="2">
+              <a:buFont typeface="Aptos" panose="020B0004020202020204" pitchFamily="34" charset="0"/>
+              <a:buChar char="→"/>
+            </a:pPr>
+            <a:r>
+              <a:rPr lang="en-CH" dirty="0"/>
+              <a:t>huge overhead, bad performance</a:t>
+            </a:r>
+          </a:p>
+          <a:p>
+            <a:pPr lvl="2">
+              <a:buFont typeface="Aptos" panose="020B0004020202020204" pitchFamily="34" charset="0"/>
+              <a:buChar char="→"/>
+            </a:pPr>
+            <a:r>
+              <a:rPr lang="en-CH" dirty="0"/>
+              <a:t>debugging tools are not great</a:t>
+            </a:r>
+          </a:p>
+          <a:p>
+            <a:pPr lvl="1"/>
+            <a:r>
+              <a:rPr lang="en-CH" dirty="0"/>
+              <a:t>Performance greatly impacts fuzz testing</a:t>
+            </a:r>
+          </a:p>
+          <a:p>
+            <a:pPr lvl="1"/>
+            <a:r>
+              <a:rPr lang="en-CH" dirty="0"/>
+              <a:t>Unit tests, step-by-step debugging for internal functions</a:t>
+            </a:r>
+          </a:p>
+        </p:txBody>
+      </p:sp>
+      <p:sp>
+        <p:nvSpPr>
+          <p:cNvPr id="4" name="Content Placeholder 3">
+            <a:extLst>
+              <a:ext uri="{FF2B5EF4-FFF2-40B4-BE49-F238E27FC236}">
+                <a16:creationId xmlns:a16="http://schemas.microsoft.com/office/drawing/2014/main" id="{F58841C8-1090-73BD-8612-E494B8001B15}"/>
+              </a:ext>
+            </a:extLst>
+          </p:cNvPr>
+          <p:cNvSpPr>
+            <a:spLocks noGrp="1"/>
+          </p:cNvSpPr>
+          <p:nvPr>
+            <p:ph sz="half" idx="2"/>
+          </p:nvPr>
+        </p:nvSpPr>
+        <p:spPr/>
+        <p:txBody>
+          <a:bodyPr/>
+          <a:lstStyle/>
+          <a:p>
+            <a:endParaRPr lang="en-CH"/>
+          </a:p>
+        </p:txBody>
+      </p:sp>
+      <p:sp>
+        <p:nvSpPr>
+          <p:cNvPr id="5" name="Date Placeholder 4">
+            <a:extLst>
+              <a:ext uri="{FF2B5EF4-FFF2-40B4-BE49-F238E27FC236}">
+                <a16:creationId xmlns:a16="http://schemas.microsoft.com/office/drawing/2014/main" id="{3EEC5EDA-4793-93D4-A820-F643F2D6FDF9}"/>
+              </a:ext>
+            </a:extLst>
+          </p:cNvPr>
+          <p:cNvSpPr>
+            <a:spLocks noGrp="1"/>
+          </p:cNvSpPr>
+          <p:nvPr>
+            <p:ph type="dt" sz="half" idx="10"/>
+          </p:nvPr>
+        </p:nvSpPr>
+        <p:spPr/>
+        <p:txBody>
+          <a:bodyPr/>
+          <a:lstStyle/>
+          <a:p>
+            <a:r>
+              <a:rPr lang="en-CH"/>
+              <a:t>30/03/2026</a:t>
+            </a:r>
+          </a:p>
+        </p:txBody>
+      </p:sp>
+      <p:sp>
+        <p:nvSpPr>
+          <p:cNvPr id="6" name="Footer Placeholder 5">
+            <a:extLst>
+              <a:ext uri="{FF2B5EF4-FFF2-40B4-BE49-F238E27FC236}">
+                <a16:creationId xmlns:a16="http://schemas.microsoft.com/office/drawing/2014/main" id="{DF860437-8E73-31B9-4ABA-36AA6E6E72AD}"/>
+              </a:ext>
+            </a:extLst>
+          </p:cNvPr>
+          <p:cNvSpPr>
+            <a:spLocks noGrp="1"/>
+          </p:cNvSpPr>
+          <p:nvPr>
+            <p:ph type="ftr" sz="quarter" idx="11"/>
+          </p:nvPr>
+        </p:nvSpPr>
+        <p:spPr/>
+        <p:txBody>
+          <a:bodyPr/>
+          <a:lstStyle/>
+          <a:p>
+            <a:r>
+              <a:rPr lang="en-US"/>
+              <a:t>Eliminating Reentrancy through Language Design</a:t>
+            </a:r>
+            <a:endParaRPr lang="en-CH"/>
+          </a:p>
+        </p:txBody>
+      </p:sp>
+      <p:sp>
+        <p:nvSpPr>
+          <p:cNvPr id="7" name="Slide Number Placeholder 6">
+            <a:extLst>
+              <a:ext uri="{FF2B5EF4-FFF2-40B4-BE49-F238E27FC236}">
+                <a16:creationId xmlns:a16="http://schemas.microsoft.com/office/drawing/2014/main" id="{D8C406F5-71EE-FBE8-90CF-182F580B400A}"/>
+              </a:ext>
+            </a:extLst>
+          </p:cNvPr>
+          <p:cNvSpPr>
+            <a:spLocks noGrp="1"/>
+          </p:cNvSpPr>
+          <p:nvPr>
+            <p:ph type="sldNum" sz="quarter" idx="12"/>
+          </p:nvPr>
+        </p:nvSpPr>
+        <p:spPr/>
+        <p:txBody>
+          <a:bodyPr/>
+          <a:lstStyle/>
+          <a:p>
+            <a:fld id="{1013ED95-016C-42D7-B550-5C99AA40E4D5}" type="slidenum">
+              <a:rPr lang="en-CH" smtClean="0"/>
+              <a:pPr/>
+              <a:t>50</a:t>
+            </a:fld>
+            <a:r>
+              <a:rPr lang="en-CH"/>
+              <a:t> / XX</a:t>
+            </a:r>
+            <a:endParaRPr lang="en-CH" dirty="0"/>
+          </a:p>
+        </p:txBody>
+      </p:sp>
+    </p:spTree>
+    <p:extLst>
+      <p:ext uri="{BB962C8B-B14F-4D97-AF65-F5344CB8AC3E}">
+        <p14:creationId xmlns:p14="http://schemas.microsoft.com/office/powerpoint/2010/main" val="101902366"/>
+      </p:ext>
+    </p:extLst>
+  </p:cSld>
+  <p:clrMapOvr>
+    <a:masterClrMapping/>
+  </p:clrMapOvr>
+</p:sld>
+</file>
+
+<file path=ppt/slides/slide51.xml><?xml version="1.0" encoding="utf-8"?>
 <p:sld xmlns:a="http://schemas.openxmlformats.org/drawingml/2006/main" xmlns:r="http://schemas.openxmlformats.org/officeDocument/2006/relationships" xmlns:p="http://schemas.openxmlformats.org/presentationml/2006/main" show="0">
   <p:cSld>
     <p:spTree>
@@ -51552,7 +51844,7 @@
             <a:fld id="{1013ED95-016C-42D7-B550-5C99AA40E4D5}" type="slidenum">
               <a:rPr lang="en-CH" smtClean="0"/>
               <a:pPr/>
-              <a:t>50</a:t>
+              <a:t>51</a:t>
             </a:fld>
             <a:r>
               <a:rPr lang="en-CH"/>
@@ -51618,7 +51910,7 @@
 </p:sld>
 </file>
 
-<file path=ppt/slides/slide51.xml><?xml version="1.0" encoding="utf-8"?>
+<file path=ppt/slides/slide52.xml><?xml version="1.0" encoding="utf-8"?>
 <p:sld xmlns:a="http://schemas.openxmlformats.org/drawingml/2006/main" xmlns:r="http://schemas.openxmlformats.org/officeDocument/2006/relationships" xmlns:p="http://schemas.openxmlformats.org/presentationml/2006/main" show="0">
   <p:cSld>
     <p:spTree>
@@ -51980,7 +52272,7 @@
             <a:fld id="{1013ED95-016C-42D7-B550-5C99AA40E4D5}" type="slidenum">
               <a:rPr lang="en-CH" smtClean="0"/>
               <a:pPr/>
-              <a:t>51</a:t>
+              <a:t>52</a:t>
             </a:fld>
             <a:r>
               <a:rPr lang="en-CH"/>
@@ -52071,7 +52363,7 @@
 </p:sld>
 </file>
 
-<file path=ppt/slides/slide52.xml><?xml version="1.0" encoding="utf-8"?>
+<file path=ppt/slides/slide53.xml><?xml version="1.0" encoding="utf-8"?>
 <p:sld xmlns:a="http://schemas.openxmlformats.org/drawingml/2006/main" xmlns:r="http://schemas.openxmlformats.org/officeDocument/2006/relationships" xmlns:p="http://schemas.openxmlformats.org/presentationml/2006/main" show="0">
   <p:cSld>
     <p:spTree>
@@ -52610,7 +52902,7 @@
             <a:fld id="{1013ED95-016C-42D7-B550-5C99AA40E4D5}" type="slidenum">
               <a:rPr lang="en-CH" smtClean="0"/>
               <a:pPr/>
-              <a:t>52</a:t>
+              <a:t>53</a:t>
             </a:fld>
             <a:r>
               <a:rPr lang="en-CH"/>
@@ -52719,7 +53011,7 @@
 </p:sld>
 </file>
 
-<file path=ppt/slides/slide53.xml><?xml version="1.0" encoding="utf-8"?>
+<file path=ppt/slides/slide54.xml><?xml version="1.0" encoding="utf-8"?>
 <p:sld xmlns:a="http://schemas.openxmlformats.org/drawingml/2006/main" xmlns:r="http://schemas.openxmlformats.org/officeDocument/2006/relationships" xmlns:p="http://schemas.openxmlformats.org/presentationml/2006/main" show="0">
   <p:cSld>
     <p:spTree>
@@ -53164,7 +53456,7 @@
             <a:fld id="{1013ED95-016C-42D7-B550-5C99AA40E4D5}" type="slidenum">
               <a:rPr lang="en-CH" smtClean="0"/>
               <a:pPr/>
-              <a:t>53</a:t>
+              <a:t>54</a:t>
             </a:fld>
             <a:r>
               <a:rPr lang="en-CH"/>

</xml_diff>